<commit_message>
docs(all): Tebello's contribution reflection
</commit_message>
<xml_diff>
--- a/docs/Practical_5_Final.pptx
+++ b/docs/Practical_5_Final.pptx
@@ -260,7 +260,7 @@
           <a:p>
             <a:fld id="{2DC5A369-CA0E-4FC6-90EE-5FA969A08EF8}" type="datetimeFigureOut">
               <a:rPr lang="en-US" smtClean="0"/>
-              <a:t>9/19/2026</a:t>
+              <a:t>9/20/2026</a:t>
             </a:fld>
             <a:endParaRPr lang="en-US" dirty="0"/>
           </a:p>
@@ -437,7 +437,7 @@
           <a:p>
             <a:fld id="{334AB06A-EEDC-421C-B5A0-5E9E5241A8E5}" type="datetimeFigureOut">
               <a:rPr lang="en-US" smtClean="0"/>
-              <a:t>9/19/2026</a:t>
+              <a:t>9/20/2026</a:t>
             </a:fld>
             <a:endParaRPr lang="en-US" dirty="0"/>
           </a:p>
@@ -7907,25 +7907,16 @@
             <a:pPr marL="0" indent="0">
               <a:buNone/>
             </a:pPr>
-            <a:endParaRPr lang="en-US" sz="3700" dirty="0"/>
+            <a:endParaRPr lang="en-ZA" sz="1600" dirty="0"/>
           </a:p>
           <a:p>
             <a:pPr marL="0" indent="0">
               <a:buNone/>
             </a:pPr>
-            <a:endParaRPr lang="en-US" sz="3700" dirty="0"/>
-          </a:p>
-          <a:p>
-            <a:pPr marL="0" indent="0">
-              <a:buNone/>
-            </a:pPr>
-            <a:endParaRPr lang="en-ZA" sz="3700" b="1" dirty="0"/>
-          </a:p>
-          <a:p>
-            <a:pPr marL="0" indent="0">
-              <a:buNone/>
-            </a:pPr>
-            <a:endParaRPr lang="en-US" sz="3700" dirty="0"/>
+            <a:r>
+              <a:rPr lang="en-ZA" dirty="0"/>
+              <a:t>We began communicating as soon as the practical was released, which allowed us to divide the work equally. As a result, every member contributed to each component: writing code, designing the UML diagrams, and using a developer tool.</a:t>
+            </a:r>
           </a:p>
           <a:p>
             <a:pPr marL="0" indent="0">
@@ -8316,7 +8307,9 @@
         </p:nvSpPr>
         <p:spPr/>
         <p:txBody>
-          <a:bodyPr/>
+          <a:bodyPr>
+            <a:normAutofit lnSpcReduction="10000"/>
+          </a:bodyPr>
           <a:lstStyle/>
           <a:p>
             <a:r>
@@ -8333,7 +8326,15 @@
           <a:p>
             <a:r>
               <a:rPr lang="en-US" dirty="0"/>
-              <a:t>Tebello:</a:t>
+              <a:t>Tebello: I worked on the main, Façade, and adapter, </a:t>
+            </a:r>
+            <a:r>
+              <a:rPr lang="en-ZA" dirty="0"/>
+              <a:t>which explains the large gap between my commits and my teammates commits</a:t>
+            </a:r>
+            <a:r>
+              <a:rPr lang="en-US" dirty="0"/>
+              <a:t>. The work was however, split equally, and each member implemented at least one pattern.</a:t>
             </a:r>
           </a:p>
           <a:p>
@@ -10824,6 +10825,15 @@
 </file>
 
 <file path=customXml/item1.xml><?xml version="1.0" encoding="utf-8"?>
+<?mso-contentType ?>
+<FormTemplates xmlns="http://schemas.microsoft.com/sharepoint/v3/contenttype/forms">
+  <Display>DocumentLibraryForm</Display>
+  <Edit>DocumentLibraryForm</Edit>
+  <New>DocumentLibraryForm</New>
+</FormTemplates>
+</file>
+
+<file path=customXml/item2.xml><?xml version="1.0" encoding="utf-8"?>
 <ct:contentTypeSchema xmlns:ct="http://schemas.microsoft.com/office/2006/metadata/contentType" xmlns:ma="http://schemas.microsoft.com/office/2006/metadata/properties/metaAttributes" ct:_="" ma:_="" ma:contentTypeName="Document" ma:contentTypeID="0x01010079F111ED35F8CC479449609E8A0923A6" ma:contentTypeVersion="28" ma:contentTypeDescription="Create a new document." ma:contentTypeScope="" ma:versionID="60f5a4f2d2b0abadcf532d48ebf9cb71">
   <xsd:schema xmlns:xsd="http://www.w3.org/2001/XMLSchema" xmlns:xs="http://www.w3.org/2001/XMLSchema" xmlns:p="http://schemas.microsoft.com/office/2006/metadata/properties" xmlns:ns1="http://schemas.microsoft.com/sharepoint/v3" xmlns:ns2="71af3243-3dd4-4a8d-8c0d-dd76da1f02a5" xmlns:ns3="16c05727-aa75-4e4a-9b5f-8a80a1165891" xmlns:ns4="230e9df3-be65-4c73-a93b-d1236ebd677e" targetNamespace="http://schemas.microsoft.com/office/2006/metadata/properties" ma:root="true" ma:fieldsID="7dd78129e6a1811f84807ad11c651531" ns1:_="" ns2:_="" ns3:_="" ns4:_="">
     <xsd:import namespace="http://schemas.microsoft.com/sharepoint/v3"/>
@@ -11135,15 +11145,6 @@
 </ct:contentTypeSchema>
 </file>
 
-<file path=customXml/item2.xml><?xml version="1.0" encoding="utf-8"?>
-<?mso-contentType ?>
-<FormTemplates xmlns="http://schemas.microsoft.com/sharepoint/v3/contenttype/forms">
-  <Display>DocumentLibraryForm</Display>
-  <Edit>DocumentLibraryForm</Edit>
-  <New>DocumentLibraryForm</New>
-</FormTemplates>
-</file>
-
 <file path=customXml/item3.xml><?xml version="1.0" encoding="utf-8"?>
 <p:properties xmlns:p="http://schemas.microsoft.com/office/2006/metadata/properties" xmlns:xsi="http://www.w3.org/2001/XMLSchema-instance" xmlns:pc="http://schemas.microsoft.com/office/infopath/2007/PartnerControls">
   <documentManagement>
@@ -11165,6 +11166,14 @@
 </file>
 
 <file path=customXml/itemProps1.xml><?xml version="1.0" encoding="utf-8"?>
+<ds:datastoreItem xmlns:ds="http://schemas.openxmlformats.org/officeDocument/2006/customXml" ds:itemID="{4C5C2001-E626-4890-B405-22B5BD1CB05A}">
+  <ds:schemaRefs>
+    <ds:schemaRef ds:uri="http://schemas.microsoft.com/sharepoint/v3/contenttype/forms"/>
+  </ds:schemaRefs>
+</ds:datastoreItem>
+</file>
+
+<file path=customXml/itemProps2.xml><?xml version="1.0" encoding="utf-8"?>
 <ds:datastoreItem xmlns:ds="http://schemas.openxmlformats.org/officeDocument/2006/customXml" ds:itemID="{55453AF4-4FB0-4B39-9296-55DED383E987}">
   <ds:schemaRefs>
     <ds:schemaRef ds:uri="http://schemas.microsoft.com/office/2006/metadata/contentType"/>
@@ -11185,14 +11194,6 @@
 </ds:datastoreItem>
 </file>
 
-<file path=customXml/itemProps2.xml><?xml version="1.0" encoding="utf-8"?>
-<ds:datastoreItem xmlns:ds="http://schemas.openxmlformats.org/officeDocument/2006/customXml" ds:itemID="{4C5C2001-E626-4890-B405-22B5BD1CB05A}">
-  <ds:schemaRefs>
-    <ds:schemaRef ds:uri="http://schemas.microsoft.com/sharepoint/v3/contenttype/forms"/>
-  </ds:schemaRefs>
-</ds:datastoreItem>
-</file>
-
 <file path=customXml/itemProps3.xml><?xml version="1.0" encoding="utf-8"?>
 <ds:datastoreItem xmlns:ds="http://schemas.openxmlformats.org/officeDocument/2006/customXml" ds:itemID="{80D7C3E5-1734-4636-9EC5-AEB06BF1FB20}">
   <ds:schemaRefs>

</xml_diff>

<commit_message>
updated UML and added my collaboration reflection
</commit_message>
<xml_diff>
--- a/docs/Practical_5_Final.pptx
+++ b/docs/Practical_5_Final.pptx
@@ -6241,8 +6241,11 @@
               <a:rPr lang="en-ZA" sz="1400" dirty="0">
                 <a:latin typeface="+mn-lt"/>
               </a:rPr>
-              <a:t>Tebello Mohohoma – </a:t>
-            </a:r>
+              <a:t>Tebello Mohohoma – u25256387</a:t>
+            </a:r>
+            <a:br>
+              <a:rPr lang="en-ZA" dirty="0"/>
+            </a:br>
             <a:br>
               <a:rPr lang="en-ZA" sz="1400" dirty="0">
                 <a:latin typeface="+mn-lt"/>
@@ -7922,6 +7925,28 @@
             <a:pPr marL="0" indent="0">
               <a:buNone/>
             </a:pPr>
+            <a:r>
+              <a:rPr lang="en-US" dirty="0"/>
+              <a:t>Despite a few minor merge conflicts and design changes along the way, we communicated well and successfully integrated our code into a final working product.</a:t>
+            </a:r>
+            <a:endParaRPr lang="en-ZA" dirty="0"/>
+          </a:p>
+          <a:p>
+            <a:pPr marL="0" indent="0">
+              <a:buNone/>
+            </a:pPr>
+            <a:endParaRPr lang="en-ZA" dirty="0"/>
+          </a:p>
+          <a:p>
+            <a:pPr marL="0" indent="0">
+              <a:buNone/>
+            </a:pPr>
+            <a:endParaRPr lang="en-ZA" dirty="0"/>
+          </a:p>
+          <a:p>
+            <a:pPr marL="0" indent="0">
+              <a:buNone/>
+            </a:pPr>
             <a:endParaRPr lang="en-US" sz="3700" dirty="0"/>
           </a:p>
         </p:txBody>
@@ -8308,13 +8333,13 @@
         <p:spPr/>
         <p:txBody>
           <a:bodyPr>
-            <a:normAutofit lnSpcReduction="10000"/>
+            <a:normAutofit fontScale="85000" lnSpcReduction="10000"/>
           </a:bodyPr>
           <a:lstStyle/>
           <a:p>
             <a:r>
               <a:rPr lang="en-US" dirty="0"/>
-              <a:t>Ashley:</a:t>
+              <a:t>Ashley: Implemented the Command and Mediator design patterns, set up the Docker build environment, worked on the initial UML and wrote the final submission PDF. Because my work involved offline architectural design and compiling the final report, my contributions are grouped into a few large commits rather than many small ones.</a:t>
             </a:r>
           </a:p>
           <a:p>
@@ -8347,6 +8372,10 @@
             <a:r>
               <a:rPr lang="en-US" dirty="0" err="1"/>
               <a:t>Navela</a:t>
+            </a:r>
+            <a:r>
+              <a:rPr lang="en-US" dirty="0"/>
+              <a:t>:</a:t>
             </a:r>
             <a:endParaRPr lang="en-ZA" dirty="0"/>
           </a:p>
@@ -8591,7 +8620,7 @@
         </p:nvSpPr>
         <p:spPr>
           <a:xfrm>
-            <a:off x="914400" y="1919673"/>
+            <a:off x="3761295" y="2315599"/>
             <a:ext cx="5400942" cy="2037030"/>
           </a:xfrm>
         </p:spPr>
@@ -8649,18 +8678,46 @@
         </p:nvPicPr>
         <p:blipFill>
           <a:blip r:embed="rId2"/>
-          <a:stretch>
-            <a:fillRect/>
-          </a:stretch>
+          <a:srcRect/>
+          <a:stretch/>
         </p:blipFill>
         <p:spPr>
           <a:xfrm>
-            <a:off x="703452" y="960289"/>
-            <a:ext cx="10574148" cy="5169720"/>
+            <a:off x="1492506" y="960289"/>
+            <a:ext cx="8996040" cy="5169720"/>
           </a:xfrm>
           <a:prstGeom prst="rect">
             <a:avLst/>
           </a:prstGeom>
+          <a:solidFill>
+            <a:srgbClr val="FFFFFF">
+              <a:shade val="85000"/>
+            </a:srgbClr>
+          </a:solidFill>
+          <a:ln w="190500" cap="rnd">
+            <a:solidFill>
+              <a:srgbClr val="FFFFFF"/>
+            </a:solidFill>
+          </a:ln>
+          <a:effectLst>
+            <a:outerShdw blurRad="50000" algn="tl" rotWithShape="0">
+              <a:srgbClr val="000000">
+                <a:alpha val="41000"/>
+              </a:srgbClr>
+            </a:outerShdw>
+          </a:effectLst>
+          <a:scene3d>
+            <a:camera prst="orthographicFront"/>
+            <a:lightRig rig="twoPt" dir="t">
+              <a:rot lat="0" lon="0" rev="7800000"/>
+            </a:lightRig>
+          </a:scene3d>
+          <a:sp3d contourW="6350">
+            <a:bevelT w="50800" h="16510"/>
+            <a:contourClr>
+              <a:srgbClr val="C0C0C0"/>
+            </a:contourClr>
+          </a:sp3d>
         </p:spPr>
       </p:pic>
     </p:spTree>
@@ -10825,12 +10882,23 @@
 </file>
 
 <file path=customXml/item1.xml><?xml version="1.0" encoding="utf-8"?>
-<?mso-contentType ?>
-<FormTemplates xmlns="http://schemas.microsoft.com/sharepoint/v3/contenttype/forms">
-  <Display>DocumentLibraryForm</Display>
-  <Edit>DocumentLibraryForm</Edit>
-  <New>DocumentLibraryForm</New>
-</FormTemplates>
+<p:properties xmlns:p="http://schemas.microsoft.com/office/2006/metadata/properties" xmlns:xsi="http://www.w3.org/2001/XMLSchema-instance" xmlns:pc="http://schemas.microsoft.com/office/infopath/2007/PartnerControls">
+  <documentManagement>
+    <Background xmlns="71af3243-3dd4-4a8d-8c0d-dd76da1f02a5">false</Background>
+    <Status xmlns="71af3243-3dd4-4a8d-8c0d-dd76da1f02a5">Not started</Status>
+    <_ip_UnifiedCompliancePolicyUIAction xmlns="http://schemas.microsoft.com/sharepoint/v3" xsi:nil="true"/>
+    <Image xmlns="71af3243-3dd4-4a8d-8c0d-dd76da1f02a5">
+      <Url xsi:nil="true"/>
+      <Description xsi:nil="true"/>
+    </Image>
+    <_ip_UnifiedCompliancePolicyProperties xmlns="http://schemas.microsoft.com/sharepoint/v3" xsi:nil="true"/>
+    <ImageTagsTaxHTField xmlns="71af3243-3dd4-4a8d-8c0d-dd76da1f02a5">
+      <Terms xmlns="http://schemas.microsoft.com/office/infopath/2007/PartnerControls"/>
+    </ImageTagsTaxHTField>
+    <TaxCatchAll xmlns="230e9df3-be65-4c73-a93b-d1236ebd677e" xsi:nil="true"/>
+    <MediaServiceKeyPoints xmlns="71af3243-3dd4-4a8d-8c0d-dd76da1f02a5" xsi:nil="true"/>
+  </documentManagement>
+</p:properties>
 </file>
 
 <file path=customXml/item2.xml><?xml version="1.0" encoding="utf-8"?>
@@ -11146,29 +11214,22 @@
 </file>
 
 <file path=customXml/item3.xml><?xml version="1.0" encoding="utf-8"?>
-<p:properties xmlns:p="http://schemas.microsoft.com/office/2006/metadata/properties" xmlns:xsi="http://www.w3.org/2001/XMLSchema-instance" xmlns:pc="http://schemas.microsoft.com/office/infopath/2007/PartnerControls">
-  <documentManagement>
-    <Background xmlns="71af3243-3dd4-4a8d-8c0d-dd76da1f02a5">false</Background>
-    <Status xmlns="71af3243-3dd4-4a8d-8c0d-dd76da1f02a5">Not started</Status>
-    <_ip_UnifiedCompliancePolicyUIAction xmlns="http://schemas.microsoft.com/sharepoint/v3" xsi:nil="true"/>
-    <Image xmlns="71af3243-3dd4-4a8d-8c0d-dd76da1f02a5">
-      <Url xsi:nil="true"/>
-      <Description xsi:nil="true"/>
-    </Image>
-    <_ip_UnifiedCompliancePolicyProperties xmlns="http://schemas.microsoft.com/sharepoint/v3" xsi:nil="true"/>
-    <ImageTagsTaxHTField xmlns="71af3243-3dd4-4a8d-8c0d-dd76da1f02a5">
-      <Terms xmlns="http://schemas.microsoft.com/office/infopath/2007/PartnerControls"/>
-    </ImageTagsTaxHTField>
-    <TaxCatchAll xmlns="230e9df3-be65-4c73-a93b-d1236ebd677e" xsi:nil="true"/>
-    <MediaServiceKeyPoints xmlns="71af3243-3dd4-4a8d-8c0d-dd76da1f02a5" xsi:nil="true"/>
-  </documentManagement>
-</p:properties>
+<?mso-contentType ?>
+<FormTemplates xmlns="http://schemas.microsoft.com/sharepoint/v3/contenttype/forms">
+  <Display>DocumentLibraryForm</Display>
+  <Edit>DocumentLibraryForm</Edit>
+  <New>DocumentLibraryForm</New>
+</FormTemplates>
 </file>
 
 <file path=customXml/itemProps1.xml><?xml version="1.0" encoding="utf-8"?>
-<ds:datastoreItem xmlns:ds="http://schemas.openxmlformats.org/officeDocument/2006/customXml" ds:itemID="{4C5C2001-E626-4890-B405-22B5BD1CB05A}">
+<ds:datastoreItem xmlns:ds="http://schemas.openxmlformats.org/officeDocument/2006/customXml" ds:itemID="{80D7C3E5-1734-4636-9EC5-AEB06BF1FB20}">
   <ds:schemaRefs>
-    <ds:schemaRef ds:uri="http://schemas.microsoft.com/sharepoint/v3/contenttype/forms"/>
+    <ds:schemaRef ds:uri="http://schemas.microsoft.com/office/2006/metadata/properties"/>
+    <ds:schemaRef ds:uri="http://schemas.microsoft.com/office/infopath/2007/PartnerControls"/>
+    <ds:schemaRef ds:uri="71af3243-3dd4-4a8d-8c0d-dd76da1f02a5"/>
+    <ds:schemaRef ds:uri="http://schemas.microsoft.com/sharepoint/v3"/>
+    <ds:schemaRef ds:uri="230e9df3-be65-4c73-a93b-d1236ebd677e"/>
   </ds:schemaRefs>
 </ds:datastoreItem>
 </file>
@@ -11195,13 +11256,9 @@
 </file>
 
 <file path=customXml/itemProps3.xml><?xml version="1.0" encoding="utf-8"?>
-<ds:datastoreItem xmlns:ds="http://schemas.openxmlformats.org/officeDocument/2006/customXml" ds:itemID="{80D7C3E5-1734-4636-9EC5-AEB06BF1FB20}">
+<ds:datastoreItem xmlns:ds="http://schemas.openxmlformats.org/officeDocument/2006/customXml" ds:itemID="{4C5C2001-E626-4890-B405-22B5BD1CB05A}">
   <ds:schemaRefs>
-    <ds:schemaRef ds:uri="http://schemas.microsoft.com/office/2006/metadata/properties"/>
-    <ds:schemaRef ds:uri="http://schemas.microsoft.com/office/infopath/2007/PartnerControls"/>
-    <ds:schemaRef ds:uri="71af3243-3dd4-4a8d-8c0d-dd76da1f02a5"/>
-    <ds:schemaRef ds:uri="http://schemas.microsoft.com/sharepoint/v3"/>
-    <ds:schemaRef ds:uri="230e9df3-be65-4c73-a93b-d1236ebd677e"/>
+    <ds:schemaRef ds:uri="http://schemas.microsoft.com/sharepoint/v3/contenttype/forms"/>
   </ds:schemaRefs>
 </ds:datastoreItem>
 </file>

</xml_diff>

<commit_message>
Added sequence diagram for Command
</commit_message>
<xml_diff>
--- a/docs/Practical_5_Final.pptx
+++ b/docs/Practical_5_Final.pptx
@@ -9890,7 +9890,14 @@
           <a:p>
             <a:r>
               <a:rPr lang="en-ZA" b="1" dirty="0"/>
-              <a:t>Behavioural Diagrams</a:t>
+              <a:t>Behavioural Diagrams – </a:t>
+            </a:r>
+            <a:br>
+              <a:rPr lang="en-ZA" b="1" dirty="0"/>
+            </a:br>
+            <a:r>
+              <a:rPr lang="en-ZA" dirty="0"/>
+              <a:t>Dispatch Emergency Unit</a:t>
             </a:r>
             <a:br>
               <a:rPr lang="en-ZA" b="1" dirty="0"/>
@@ -9899,31 +9906,37 @@
           </a:p>
         </p:txBody>
       </p:sp>
-      <p:sp>
-        <p:nvSpPr>
-          <p:cNvPr id="3" name="Content Placeholder 2">
-            <a:extLst>
-              <a:ext uri="{FF2B5EF4-FFF2-40B4-BE49-F238E27FC236}">
-                <a16:creationId xmlns:a16="http://schemas.microsoft.com/office/drawing/2014/main" id="{DA35AE32-61E9-0333-B11E-EA46D9A785B9}"/>
-              </a:ext>
-            </a:extLst>
-          </p:cNvPr>
-          <p:cNvSpPr>
-            <a:spLocks noGrp="1"/>
-          </p:cNvSpPr>
+      <p:pic>
+        <p:nvPicPr>
+          <p:cNvPr id="6" name="Content Placeholder 5">
+            <a:extLst>
+              <a:ext uri="{FF2B5EF4-FFF2-40B4-BE49-F238E27FC236}">
+                <a16:creationId xmlns:a16="http://schemas.microsoft.com/office/drawing/2014/main" id="{89541FE2-B8CF-F9F6-9231-BC6155E0C0B1}"/>
+              </a:ext>
+            </a:extLst>
+          </p:cNvPr>
+          <p:cNvPicPr>
+            <a:picLocks noGrp="1" noChangeAspect="1"/>
+          </p:cNvPicPr>
           <p:nvPr>
             <p:ph sz="quarter" idx="10"/>
           </p:nvPr>
-        </p:nvSpPr>
-        <p:spPr/>
-        <p:txBody>
-          <a:bodyPr/>
-          <a:lstStyle/>
-          <a:p>
-            <a:endParaRPr lang="en-ZA" dirty="0"/>
-          </a:p>
-        </p:txBody>
-      </p:sp>
+        </p:nvPicPr>
+        <p:blipFill>
+          <a:blip r:embed="rId2"/>
+          <a:srcRect/>
+          <a:stretch/>
+        </p:blipFill>
+        <p:spPr>
+          <a:xfrm>
+            <a:off x="2252571" y="2273300"/>
+            <a:ext cx="7763058" cy="3317875"/>
+          </a:xfrm>
+          <a:prstGeom prst="rect">
+            <a:avLst/>
+          </a:prstGeom>
+        </p:spPr>
+      </p:pic>
       <p:sp>
         <p:nvSpPr>
           <p:cNvPr id="4" name="Slide Number Placeholder 3">
@@ -10882,26 +10895,6 @@
 </file>
 
 <file path=customXml/item1.xml><?xml version="1.0" encoding="utf-8"?>
-<p:properties xmlns:p="http://schemas.microsoft.com/office/2006/metadata/properties" xmlns:xsi="http://www.w3.org/2001/XMLSchema-instance" xmlns:pc="http://schemas.microsoft.com/office/infopath/2007/PartnerControls">
-  <documentManagement>
-    <Background xmlns="71af3243-3dd4-4a8d-8c0d-dd76da1f02a5">false</Background>
-    <Status xmlns="71af3243-3dd4-4a8d-8c0d-dd76da1f02a5">Not started</Status>
-    <_ip_UnifiedCompliancePolicyUIAction xmlns="http://schemas.microsoft.com/sharepoint/v3" xsi:nil="true"/>
-    <Image xmlns="71af3243-3dd4-4a8d-8c0d-dd76da1f02a5">
-      <Url xsi:nil="true"/>
-      <Description xsi:nil="true"/>
-    </Image>
-    <_ip_UnifiedCompliancePolicyProperties xmlns="http://schemas.microsoft.com/sharepoint/v3" xsi:nil="true"/>
-    <ImageTagsTaxHTField xmlns="71af3243-3dd4-4a8d-8c0d-dd76da1f02a5">
-      <Terms xmlns="http://schemas.microsoft.com/office/infopath/2007/PartnerControls"/>
-    </ImageTagsTaxHTField>
-    <TaxCatchAll xmlns="230e9df3-be65-4c73-a93b-d1236ebd677e" xsi:nil="true"/>
-    <MediaServiceKeyPoints xmlns="71af3243-3dd4-4a8d-8c0d-dd76da1f02a5" xsi:nil="true"/>
-  </documentManagement>
-</p:properties>
-</file>
-
-<file path=customXml/item2.xml><?xml version="1.0" encoding="utf-8"?>
 <ct:contentTypeSchema xmlns:ct="http://schemas.microsoft.com/office/2006/metadata/contentType" xmlns:ma="http://schemas.microsoft.com/office/2006/metadata/properties/metaAttributes" ct:_="" ma:_="" ma:contentTypeName="Document" ma:contentTypeID="0x01010079F111ED35F8CC479449609E8A0923A6" ma:contentTypeVersion="28" ma:contentTypeDescription="Create a new document." ma:contentTypeScope="" ma:versionID="60f5a4f2d2b0abadcf532d48ebf9cb71">
   <xsd:schema xmlns:xsd="http://www.w3.org/2001/XMLSchema" xmlns:xs="http://www.w3.org/2001/XMLSchema" xmlns:p="http://schemas.microsoft.com/office/2006/metadata/properties" xmlns:ns1="http://schemas.microsoft.com/sharepoint/v3" xmlns:ns2="71af3243-3dd4-4a8d-8c0d-dd76da1f02a5" xmlns:ns3="16c05727-aa75-4e4a-9b5f-8a80a1165891" xmlns:ns4="230e9df3-be65-4c73-a93b-d1236ebd677e" targetNamespace="http://schemas.microsoft.com/office/2006/metadata/properties" ma:root="true" ma:fieldsID="7dd78129e6a1811f84807ad11c651531" ns1:_="" ns2:_="" ns3:_="" ns4:_="">
     <xsd:import namespace="http://schemas.microsoft.com/sharepoint/v3"/>
@@ -11213,6 +11206,26 @@
 </ct:contentTypeSchema>
 </file>
 
+<file path=customXml/item2.xml><?xml version="1.0" encoding="utf-8"?>
+<p:properties xmlns:p="http://schemas.microsoft.com/office/2006/metadata/properties" xmlns:xsi="http://www.w3.org/2001/XMLSchema-instance" xmlns:pc="http://schemas.microsoft.com/office/infopath/2007/PartnerControls">
+  <documentManagement>
+    <Background xmlns="71af3243-3dd4-4a8d-8c0d-dd76da1f02a5">false</Background>
+    <Status xmlns="71af3243-3dd4-4a8d-8c0d-dd76da1f02a5">Not started</Status>
+    <_ip_UnifiedCompliancePolicyUIAction xmlns="http://schemas.microsoft.com/sharepoint/v3" xsi:nil="true"/>
+    <Image xmlns="71af3243-3dd4-4a8d-8c0d-dd76da1f02a5">
+      <Url xsi:nil="true"/>
+      <Description xsi:nil="true"/>
+    </Image>
+    <_ip_UnifiedCompliancePolicyProperties xmlns="http://schemas.microsoft.com/sharepoint/v3" xsi:nil="true"/>
+    <ImageTagsTaxHTField xmlns="71af3243-3dd4-4a8d-8c0d-dd76da1f02a5">
+      <Terms xmlns="http://schemas.microsoft.com/office/infopath/2007/PartnerControls"/>
+    </ImageTagsTaxHTField>
+    <TaxCatchAll xmlns="230e9df3-be65-4c73-a93b-d1236ebd677e" xsi:nil="true"/>
+    <MediaServiceKeyPoints xmlns="71af3243-3dd4-4a8d-8c0d-dd76da1f02a5" xsi:nil="true"/>
+  </documentManagement>
+</p:properties>
+</file>
+
 <file path=customXml/item3.xml><?xml version="1.0" encoding="utf-8"?>
 <?mso-contentType ?>
 <FormTemplates xmlns="http://schemas.microsoft.com/sharepoint/v3/contenttype/forms">
@@ -11223,18 +11236,6 @@
 </file>
 
 <file path=customXml/itemProps1.xml><?xml version="1.0" encoding="utf-8"?>
-<ds:datastoreItem xmlns:ds="http://schemas.openxmlformats.org/officeDocument/2006/customXml" ds:itemID="{80D7C3E5-1734-4636-9EC5-AEB06BF1FB20}">
-  <ds:schemaRefs>
-    <ds:schemaRef ds:uri="http://schemas.microsoft.com/office/2006/metadata/properties"/>
-    <ds:schemaRef ds:uri="http://schemas.microsoft.com/office/infopath/2007/PartnerControls"/>
-    <ds:schemaRef ds:uri="71af3243-3dd4-4a8d-8c0d-dd76da1f02a5"/>
-    <ds:schemaRef ds:uri="http://schemas.microsoft.com/sharepoint/v3"/>
-    <ds:schemaRef ds:uri="230e9df3-be65-4c73-a93b-d1236ebd677e"/>
-  </ds:schemaRefs>
-</ds:datastoreItem>
-</file>
-
-<file path=customXml/itemProps2.xml><?xml version="1.0" encoding="utf-8"?>
 <ds:datastoreItem xmlns:ds="http://schemas.openxmlformats.org/officeDocument/2006/customXml" ds:itemID="{55453AF4-4FB0-4B39-9296-55DED383E987}">
   <ds:schemaRefs>
     <ds:schemaRef ds:uri="http://schemas.microsoft.com/office/2006/metadata/contentType"/>
@@ -11255,6 +11256,18 @@
 </ds:datastoreItem>
 </file>
 
+<file path=customXml/itemProps2.xml><?xml version="1.0" encoding="utf-8"?>
+<ds:datastoreItem xmlns:ds="http://schemas.openxmlformats.org/officeDocument/2006/customXml" ds:itemID="{80D7C3E5-1734-4636-9EC5-AEB06BF1FB20}">
+  <ds:schemaRefs>
+    <ds:schemaRef ds:uri="http://schemas.microsoft.com/office/2006/metadata/properties"/>
+    <ds:schemaRef ds:uri="http://schemas.microsoft.com/office/infopath/2007/PartnerControls"/>
+    <ds:schemaRef ds:uri="71af3243-3dd4-4a8d-8c0d-dd76da1f02a5"/>
+    <ds:schemaRef ds:uri="http://schemas.microsoft.com/sharepoint/v3"/>
+    <ds:schemaRef ds:uri="230e9df3-be65-4c73-a93b-d1236ebd677e"/>
+  </ds:schemaRefs>
+</ds:datastoreItem>
+</file>
+
 <file path=customXml/itemProps3.xml><?xml version="1.0" encoding="utf-8"?>
 <ds:datastoreItem xmlns:ds="http://schemas.openxmlformats.org/officeDocument/2006/customXml" ds:itemID="{4C5C2001-E626-4890-B405-22B5BD1CB05A}">
   <ds:schemaRefs>

</xml_diff>

<commit_message>
added Navela's student number to doc
</commit_message>
<xml_diff>
--- a/docs/Practical_5_Final.pptx
+++ b/docs/Practical_5_Final.pptx
@@ -6251,11 +6251,6 @@
                 <a:latin typeface="+mn-lt"/>
               </a:rPr>
             </a:br>
-            <a:br>
-              <a:rPr lang="en-ZA" sz="1400" dirty="0">
-                <a:latin typeface="+mn-lt"/>
-              </a:rPr>
-            </a:br>
             <a:r>
               <a:rPr lang="en-ZA" sz="1400" dirty="0">
                 <a:latin typeface="+mn-lt"/>
@@ -6266,6 +6261,15 @@
               <a:rPr lang="en-ZA" sz="1400" dirty="0"/>
               <a:t>– </a:t>
             </a:r>
+            <a:r>
+              <a:rPr lang="en-ZA" sz="1400" dirty="0">
+                <a:latin typeface="+mn-lt"/>
+              </a:rPr>
+              <a:t>u25254686</a:t>
+            </a:r>
+            <a:br>
+              <a:rPr lang="en-ZA" dirty="0"/>
+            </a:br>
             <a:br>
               <a:rPr lang="en-ZA" sz="1400" dirty="0"/>
             </a:br>

</xml_diff>

<commit_message>
Final composed PDF ready for submission
</commit_message>
<xml_diff>
--- a/docs/Practical_5_Final.pptx
+++ b/docs/Practical_5_Final.pptx
@@ -6369,7 +6369,11 @@
           <a:p>
             <a:r>
               <a:rPr lang="en-ZA" b="1" dirty="0"/>
-              <a:t>Behavioural Diagrams</a:t>
+              <a:t>Behavioural Diagrams - </a:t>
+            </a:r>
+            <a:r>
+              <a:rPr lang="en-ZA" dirty="0"/>
+              <a:t>Activity diagram</a:t>
             </a:r>
             <a:br>
               <a:rPr lang="en-ZA" b="1" dirty="0"/>
@@ -6378,31 +6382,38 @@
           </a:p>
         </p:txBody>
       </p:sp>
-      <p:sp>
-        <p:nvSpPr>
-          <p:cNvPr id="3" name="Content Placeholder 2">
-            <a:extLst>
-              <a:ext uri="{FF2B5EF4-FFF2-40B4-BE49-F238E27FC236}">
-                <a16:creationId xmlns:a16="http://schemas.microsoft.com/office/drawing/2014/main" id="{89CA08C1-5B58-2742-1CD1-C3538FC4E9D6}"/>
-              </a:ext>
-            </a:extLst>
-          </p:cNvPr>
-          <p:cNvSpPr>
-            <a:spLocks noGrp="1"/>
-          </p:cNvSpPr>
+      <p:pic>
+        <p:nvPicPr>
+          <p:cNvPr id="6" name="Content Placeholder 5">
+            <a:extLst>
+              <a:ext uri="{FF2B5EF4-FFF2-40B4-BE49-F238E27FC236}">
+                <a16:creationId xmlns:a16="http://schemas.microsoft.com/office/drawing/2014/main" id="{129B6363-C1C4-F14C-128E-532A442F1946}"/>
+              </a:ext>
+            </a:extLst>
+          </p:cNvPr>
+          <p:cNvPicPr>
+            <a:picLocks noGrp="1" noChangeAspect="1"/>
+          </p:cNvPicPr>
           <p:nvPr>
             <p:ph sz="quarter" idx="10"/>
           </p:nvPr>
-        </p:nvSpPr>
-        <p:spPr/>
-        <p:txBody>
-          <a:bodyPr/>
-          <a:lstStyle/>
-          <a:p>
-            <a:endParaRPr lang="en-ZA" dirty="0"/>
-          </a:p>
-        </p:txBody>
-      </p:sp>
+        </p:nvPicPr>
+        <p:blipFill>
+          <a:blip r:embed="rId2"/>
+          <a:stretch>
+            <a:fillRect/>
+          </a:stretch>
+        </p:blipFill>
+        <p:spPr>
+          <a:xfrm>
+            <a:off x="3627692" y="2273300"/>
+            <a:ext cx="5012816" cy="3317875"/>
+          </a:xfrm>
+          <a:prstGeom prst="rect">
+            <a:avLst/>
+          </a:prstGeom>
+        </p:spPr>
+      </p:pic>
       <p:sp>
         <p:nvSpPr>
           <p:cNvPr id="4" name="Slide Number Placeholder 3">
@@ -8337,13 +8348,13 @@
         <p:spPr/>
         <p:txBody>
           <a:bodyPr>
-            <a:normAutofit fontScale="85000" lnSpcReduction="10000"/>
+            <a:normAutofit fontScale="77500" lnSpcReduction="20000"/>
           </a:bodyPr>
           <a:lstStyle/>
           <a:p>
             <a:r>
               <a:rPr lang="en-US" dirty="0"/>
-              <a:t>Ashley: Implemented the Command and Mediator design patterns, set up the Docker build environment, worked on the initial UML and wrote the final submission PDF. Because my work involved offline architectural design and compiling the final report, my contributions are grouped into a few large commits rather than many small ones.</a:t>
+              <a:t>Ashley: I implemented the Command and Mediator design patterns, set up the Docker build environment, worked on the initial UML and wrote the final submission PDF. Because my work involved offline architectural design and compiling the final report, my contributions are grouped into a few large commits rather than many small ones.</a:t>
             </a:r>
           </a:p>
           <a:p>
@@ -8378,8 +8389,12 @@
               <a:t>Navela</a:t>
             </a:r>
             <a:r>
+              <a:rPr lang="en-US"/>
+              <a:t>: I implemented </a:t>
+            </a:r>
+            <a:r>
               <a:rPr lang="en-US" dirty="0"/>
-              <a:t>:</a:t>
+              <a:t>the State design pattern to manage dynamic transitions between incident phases (Detection, Response, Recovery). Also designed the Facade sequence diagram and the final activity diagram for the UML documentation.</a:t>
             </a:r>
             <a:endParaRPr lang="en-ZA" dirty="0"/>
           </a:p>
@@ -10030,7 +10045,11 @@
           <a:p>
             <a:r>
               <a:rPr lang="en-ZA" b="1" dirty="0"/>
-              <a:t>Behavioural Diagrams</a:t>
+              <a:t>Behavioural Diagrams - </a:t>
+            </a:r>
+            <a:r>
+              <a:rPr lang="en-ZA" dirty="0"/>
+              <a:t>Facade</a:t>
             </a:r>
             <a:br>
               <a:rPr lang="en-ZA" b="1" dirty="0"/>
@@ -10039,31 +10058,38 @@
           </a:p>
         </p:txBody>
       </p:sp>
-      <p:sp>
-        <p:nvSpPr>
-          <p:cNvPr id="3" name="Content Placeholder 2">
-            <a:extLst>
-              <a:ext uri="{FF2B5EF4-FFF2-40B4-BE49-F238E27FC236}">
-                <a16:creationId xmlns:a16="http://schemas.microsoft.com/office/drawing/2014/main" id="{F16E0D52-38CE-08A2-BF70-9AF9114D432E}"/>
-              </a:ext>
-            </a:extLst>
-          </p:cNvPr>
-          <p:cNvSpPr>
-            <a:spLocks noGrp="1"/>
-          </p:cNvSpPr>
+      <p:pic>
+        <p:nvPicPr>
+          <p:cNvPr id="6" name="Content Placeholder 5">
+            <a:extLst>
+              <a:ext uri="{FF2B5EF4-FFF2-40B4-BE49-F238E27FC236}">
+                <a16:creationId xmlns:a16="http://schemas.microsoft.com/office/drawing/2014/main" id="{5194CE8B-5383-CDA0-E36E-A29AB2B29300}"/>
+              </a:ext>
+            </a:extLst>
+          </p:cNvPr>
+          <p:cNvPicPr>
+            <a:picLocks noGrp="1" noChangeAspect="1"/>
+          </p:cNvPicPr>
           <p:nvPr>
             <p:ph sz="quarter" idx="10"/>
           </p:nvPr>
-        </p:nvSpPr>
-        <p:spPr/>
-        <p:txBody>
-          <a:bodyPr/>
-          <a:lstStyle/>
-          <a:p>
-            <a:endParaRPr lang="en-ZA" dirty="0"/>
-          </a:p>
-        </p:txBody>
-      </p:sp>
+        </p:nvPicPr>
+        <p:blipFill>
+          <a:blip r:embed="rId2"/>
+          <a:stretch>
+            <a:fillRect/>
+          </a:stretch>
+        </p:blipFill>
+        <p:spPr>
+          <a:xfrm>
+            <a:off x="2692333" y="2273300"/>
+            <a:ext cx="6883533" cy="3317875"/>
+          </a:xfrm>
+          <a:prstGeom prst="rect">
+            <a:avLst/>
+          </a:prstGeom>
+        </p:spPr>
+      </p:pic>
       <p:sp>
         <p:nvSpPr>
           <p:cNvPr id="4" name="Slide Number Placeholder 3">
@@ -10899,6 +10925,26 @@
 </file>
 
 <file path=customXml/item1.xml><?xml version="1.0" encoding="utf-8"?>
+<p:properties xmlns:p="http://schemas.microsoft.com/office/2006/metadata/properties" xmlns:xsi="http://www.w3.org/2001/XMLSchema-instance" xmlns:pc="http://schemas.microsoft.com/office/infopath/2007/PartnerControls">
+  <documentManagement>
+    <Background xmlns="71af3243-3dd4-4a8d-8c0d-dd76da1f02a5">false</Background>
+    <Status xmlns="71af3243-3dd4-4a8d-8c0d-dd76da1f02a5">Not started</Status>
+    <_ip_UnifiedCompliancePolicyUIAction xmlns="http://schemas.microsoft.com/sharepoint/v3" xsi:nil="true"/>
+    <Image xmlns="71af3243-3dd4-4a8d-8c0d-dd76da1f02a5">
+      <Url xsi:nil="true"/>
+      <Description xsi:nil="true"/>
+    </Image>
+    <_ip_UnifiedCompliancePolicyProperties xmlns="http://schemas.microsoft.com/sharepoint/v3" xsi:nil="true"/>
+    <ImageTagsTaxHTField xmlns="71af3243-3dd4-4a8d-8c0d-dd76da1f02a5">
+      <Terms xmlns="http://schemas.microsoft.com/office/infopath/2007/PartnerControls"/>
+    </ImageTagsTaxHTField>
+    <TaxCatchAll xmlns="230e9df3-be65-4c73-a93b-d1236ebd677e" xsi:nil="true"/>
+    <MediaServiceKeyPoints xmlns="71af3243-3dd4-4a8d-8c0d-dd76da1f02a5" xsi:nil="true"/>
+  </documentManagement>
+</p:properties>
+</file>
+
+<file path=customXml/item2.xml><?xml version="1.0" encoding="utf-8"?>
 <ct:contentTypeSchema xmlns:ct="http://schemas.microsoft.com/office/2006/metadata/contentType" xmlns:ma="http://schemas.microsoft.com/office/2006/metadata/properties/metaAttributes" ct:_="" ma:_="" ma:contentTypeName="Document" ma:contentTypeID="0x01010079F111ED35F8CC479449609E8A0923A6" ma:contentTypeVersion="28" ma:contentTypeDescription="Create a new document." ma:contentTypeScope="" ma:versionID="60f5a4f2d2b0abadcf532d48ebf9cb71">
   <xsd:schema xmlns:xsd="http://www.w3.org/2001/XMLSchema" xmlns:xs="http://www.w3.org/2001/XMLSchema" xmlns:p="http://schemas.microsoft.com/office/2006/metadata/properties" xmlns:ns1="http://schemas.microsoft.com/sharepoint/v3" xmlns:ns2="71af3243-3dd4-4a8d-8c0d-dd76da1f02a5" xmlns:ns3="16c05727-aa75-4e4a-9b5f-8a80a1165891" xmlns:ns4="230e9df3-be65-4c73-a93b-d1236ebd677e" targetNamespace="http://schemas.microsoft.com/office/2006/metadata/properties" ma:root="true" ma:fieldsID="7dd78129e6a1811f84807ad11c651531" ns1:_="" ns2:_="" ns3:_="" ns4:_="">
     <xsd:import namespace="http://schemas.microsoft.com/sharepoint/v3"/>
@@ -11210,26 +11256,6 @@
 </ct:contentTypeSchema>
 </file>
 
-<file path=customXml/item2.xml><?xml version="1.0" encoding="utf-8"?>
-<p:properties xmlns:p="http://schemas.microsoft.com/office/2006/metadata/properties" xmlns:xsi="http://www.w3.org/2001/XMLSchema-instance" xmlns:pc="http://schemas.microsoft.com/office/infopath/2007/PartnerControls">
-  <documentManagement>
-    <Background xmlns="71af3243-3dd4-4a8d-8c0d-dd76da1f02a5">false</Background>
-    <Status xmlns="71af3243-3dd4-4a8d-8c0d-dd76da1f02a5">Not started</Status>
-    <_ip_UnifiedCompliancePolicyUIAction xmlns="http://schemas.microsoft.com/sharepoint/v3" xsi:nil="true"/>
-    <Image xmlns="71af3243-3dd4-4a8d-8c0d-dd76da1f02a5">
-      <Url xsi:nil="true"/>
-      <Description xsi:nil="true"/>
-    </Image>
-    <_ip_UnifiedCompliancePolicyProperties xmlns="http://schemas.microsoft.com/sharepoint/v3" xsi:nil="true"/>
-    <ImageTagsTaxHTField xmlns="71af3243-3dd4-4a8d-8c0d-dd76da1f02a5">
-      <Terms xmlns="http://schemas.microsoft.com/office/infopath/2007/PartnerControls"/>
-    </ImageTagsTaxHTField>
-    <TaxCatchAll xmlns="230e9df3-be65-4c73-a93b-d1236ebd677e" xsi:nil="true"/>
-    <MediaServiceKeyPoints xmlns="71af3243-3dd4-4a8d-8c0d-dd76da1f02a5" xsi:nil="true"/>
-  </documentManagement>
-</p:properties>
-</file>
-
 <file path=customXml/item3.xml><?xml version="1.0" encoding="utf-8"?>
 <?mso-contentType ?>
 <FormTemplates xmlns="http://schemas.microsoft.com/sharepoint/v3/contenttype/forms">
@@ -11240,6 +11266,18 @@
 </file>
 
 <file path=customXml/itemProps1.xml><?xml version="1.0" encoding="utf-8"?>
+<ds:datastoreItem xmlns:ds="http://schemas.openxmlformats.org/officeDocument/2006/customXml" ds:itemID="{80D7C3E5-1734-4636-9EC5-AEB06BF1FB20}">
+  <ds:schemaRefs>
+    <ds:schemaRef ds:uri="http://schemas.microsoft.com/office/2006/metadata/properties"/>
+    <ds:schemaRef ds:uri="http://schemas.microsoft.com/office/infopath/2007/PartnerControls"/>
+    <ds:schemaRef ds:uri="71af3243-3dd4-4a8d-8c0d-dd76da1f02a5"/>
+    <ds:schemaRef ds:uri="http://schemas.microsoft.com/sharepoint/v3"/>
+    <ds:schemaRef ds:uri="230e9df3-be65-4c73-a93b-d1236ebd677e"/>
+  </ds:schemaRefs>
+</ds:datastoreItem>
+</file>
+
+<file path=customXml/itemProps2.xml><?xml version="1.0" encoding="utf-8"?>
 <ds:datastoreItem xmlns:ds="http://schemas.openxmlformats.org/officeDocument/2006/customXml" ds:itemID="{55453AF4-4FB0-4B39-9296-55DED383E987}">
   <ds:schemaRefs>
     <ds:schemaRef ds:uri="http://schemas.microsoft.com/office/2006/metadata/contentType"/>
@@ -11260,18 +11298,6 @@
 </ds:datastoreItem>
 </file>
 
-<file path=customXml/itemProps2.xml><?xml version="1.0" encoding="utf-8"?>
-<ds:datastoreItem xmlns:ds="http://schemas.openxmlformats.org/officeDocument/2006/customXml" ds:itemID="{80D7C3E5-1734-4636-9EC5-AEB06BF1FB20}">
-  <ds:schemaRefs>
-    <ds:schemaRef ds:uri="http://schemas.microsoft.com/office/2006/metadata/properties"/>
-    <ds:schemaRef ds:uri="http://schemas.microsoft.com/office/infopath/2007/PartnerControls"/>
-    <ds:schemaRef ds:uri="71af3243-3dd4-4a8d-8c0d-dd76da1f02a5"/>
-    <ds:schemaRef ds:uri="http://schemas.microsoft.com/sharepoint/v3"/>
-    <ds:schemaRef ds:uri="230e9df3-be65-4c73-a93b-d1236ebd677e"/>
-  </ds:schemaRefs>
-</ds:datastoreItem>
-</file>
-
 <file path=customXml/itemProps3.xml><?xml version="1.0" encoding="utf-8"?>
 <ds:datastoreItem xmlns:ds="http://schemas.openxmlformats.org/officeDocument/2006/customXml" ds:itemID="{4C5C2001-E626-4890-B405-22B5BD1CB05A}">
   <ds:schemaRefs>

</xml_diff>